<commit_message>
deck: fix corrupt pptx — integer EMU for arrow connectors
add_connector emitted fractional EMU coords (e.g. x="3016173.75", cy="0.0") from
float division, which is invalid OOXML and made PowerPoint flag the file corrupt.
Coerce the connector coordinates to int. Verified: 0 fractional-EMU attributes,
all slides well-formed, reopens cleanly; Poppins/palette unchanged.

Co-Authored-By: Claude Opus 4.8 (1M context) <noreply@anthropic.com>
</commit_message>
<xml_diff>
--- a/docs/agentic-architecture-deck.pptx
+++ b/docs/agentic-architecture-deck.pptx
@@ -6125,8 +6125,8 @@
         </p:nvCxnSpPr>
         <p:spPr>
           <a:xfrm>
-            <a:off x="3016173.75" y="3589020.0"/>
-            <a:ext cx="269240.0" cy="0.0"/>
+            <a:off x="3016173" y="3589020"/>
+            <a:ext cx="269240" cy="0"/>
           </a:xfrm>
           <a:prstGeom prst="bentConnector3">
             <a:avLst/>
@@ -6500,8 +6500,8 @@
         </p:nvCxnSpPr>
         <p:spPr>
           <a:xfrm>
-            <a:off x="5961227.5" y="3589020.0"/>
-            <a:ext cx="269240.0" cy="0.0"/>
+            <a:off x="5961227" y="3589020"/>
+            <a:ext cx="269240" cy="0"/>
           </a:xfrm>
           <a:prstGeom prst="bentConnector3">
             <a:avLst/>
@@ -6875,8 +6875,8 @@
         </p:nvCxnSpPr>
         <p:spPr>
           <a:xfrm>
-            <a:off x="8906281.25" y="3589020.0"/>
-            <a:ext cx="269240.0" cy="0.0"/>
+            <a:off x="8906281" y="3589020"/>
+            <a:ext cx="269240" cy="0"/>
           </a:xfrm>
           <a:prstGeom prst="bentConnector3">
             <a:avLst/>

</xml_diff>